<commit_message>
docs(ppt): add 7 result-image slides to presentation
New image slides (embedded PNGs):
  - ViT-Small confusion matrix
  - YOLOv8m 30ep training curves + confusion matrix (2-up)
  - Segmentation qualitative samples (original | GT | pred, 2-up)
  - P1b backbone scatter plot (params/latency/throughput vs accuracy)
  - Grad-CAM on normal samples
  - Grad-CAM on canker samples

All images archived in docs/ppt_assets/ so the pptx remains rebuildable.

Co-Authored-By: Claude Opus 4.6 (1M context) <noreply@anthropic.com>
</commit_message>
<xml_diff>
--- a/docs/disease_01_presentation.pptx
+++ b/docs/disease_01_presentation.pptx
@@ -15,10 +15,10 @@
     <p:sldId id="263" r:id="rId14"/>
     <p:sldId id="264" r:id="rId15"/>
     <p:sldId id="265" r:id="rId16"/>
-    <p:sldId id="266" r:id="rId17"/>
-    <p:sldId id="267" r:id="rId18"/>
-    <p:sldId id="268" r:id="rId19"/>
-    <p:sldId id="269" r:id="rId20"/>
+    <p:sldId id="266" r:id="rId18"/>
+    <p:sldId id="267" r:id="rId19"/>
+    <p:sldId id="268" r:id="rId20"/>
+    <p:sldId id="269" r:id="rId21"/>
     <p:sldId id="270" r:id="rId22"/>
     <p:sldId id="271" r:id="rId23"/>
     <p:sldId id="272" r:id="rId24"/>
@@ -38,6 +38,12 @@
     <p:sldId id="286" r:id="rId38"/>
     <p:sldId id="287" r:id="rId39"/>
     <p:sldId id="288" r:id="rId40"/>
+    <p:sldId id="289" r:id="rId41"/>
+    <p:sldId id="290" r:id="rId42"/>
+    <p:sldId id="291" r:id="rId43"/>
+    <p:sldId id="292" r:id="rId44"/>
+    <p:sldId id="293" r:id="rId45"/>
+    <p:sldId id="294" r:id="rId46"/>
   </p:sldIdLst>
   <p:sldSz cx="12191695" cy="6858000" type="screen4x3"/>
   <p:notesSz cx="6858000" cy="9144000"/>
@@ -534,7 +540,77 @@
           <a:lstStyle/>
           <a:p>
             <a:r>
-              <a:t>ViT-Small이 정확도 최고 + latency 최저 — Apple MPS에서 Transformer가 기존 CNN보다 빠르게 동작한 흥미로운 발견. MobileNetV3은 throughput 왕 (264 FPS, 4.2M params).</a:t>
+              <a:t>P1b에서 최고 성능을 보인 ViT-Small의 confusion matrix. 궤양병 recall 거의 완벽.</a:t>
+            </a:r>
+          </a:p>
+        </p:txBody>
+      </p:sp>
+      <p:sp>
+        <p:nvSpPr>
+          <p:cNvPr id="4" name="Slide Number Placeholder 3"/>
+          <p:cNvSpPr>
+            <a:spLocks noGrp="1"/>
+          </p:cNvSpPr>
+          <p:nvPr>
+            <p:ph type="sldNum" idx="5" sz="quarter"/>
+          </p:nvPr>
+        </p:nvSpPr>
+        <p:spPr/>
+      </p:sp>
+    </p:spTree>
+  </p:cSld>
+  <p:clrMapOvr>
+    <a:masterClrMapping/>
+  </p:clrMapOvr>
+</p:notes>
+</file>
+
+<file path=ppt/notesSlides/notesSlide10.xml><?xml version="1.0" encoding="utf-8"?>
+<p:notes xmlns:a="http://schemas.openxmlformats.org/drawingml/2006/main" xmlns:p="http://schemas.openxmlformats.org/presentationml/2006/main" xmlns:r="http://schemas.openxmlformats.org/officeDocument/2006/relationships">
+  <p:cSld>
+    <p:spTree>
+      <p:nvGrpSpPr>
+        <p:cNvPr id="1" name=""/>
+        <p:cNvGrpSpPr/>
+        <p:nvPr/>
+      </p:nvGrpSpPr>
+      <p:grpSpPr>
+        <a:xfrm>
+          <a:off x="0" y="0"/>
+          <a:ext cx="0" cy="0"/>
+          <a:chOff x="0" y="0"/>
+          <a:chExt cx="0" cy="0"/>
+        </a:xfrm>
+      </p:grpSpPr>
+      <p:sp>
+        <p:nvSpPr>
+          <p:cNvPr id="2" name="Slide Image Placeholder 1"/>
+          <p:cNvSpPr>
+            <a:spLocks noGrp="1"/>
+          </p:cNvSpPr>
+          <p:nvPr>
+            <p:ph type="sldImg" idx="2"/>
+          </p:nvPr>
+        </p:nvSpPr>
+        <p:spPr/>
+      </p:sp>
+      <p:sp>
+        <p:nvSpPr>
+          <p:cNvPr id="3" name="Notes Placeholder 2"/>
+          <p:cNvSpPr>
+            <a:spLocks noGrp="1"/>
+          </p:cNvSpPr>
+          <p:nvPr>
+            <p:ph type="body" idx="3" sz="quarter"/>
+          </p:nvPr>
+        </p:nvSpPr>
+        <p:spPr/>
+        <p:txBody>
+          <a:bodyPr/>
+          <a:lstStyle/>
+          <a:p>
+            <a:r>
+              <a:t>병변성 패턴을 가진 영역에 모델 attention이 몰림.</a:t>
             </a:r>
           </a:p>
         </p:txBody>
@@ -604,7 +680,7 @@
           <a:lstStyle/>
           <a:p>
             <a:r>
-              <a:t>5 epoch로는 yolov8m이 under-fit. yolov8s가 정확도+속도 균형 최고. yolov8n은 엣지/모바일 유력 (168 FPS).</a:t>
+              <a:t>P4-A1 장기학습 결과: under-fit이었던 yolov8m이 30ep에 mAP@0.5 0.9945 달성.</a:t>
             </a:r>
           </a:p>
         </p:txBody>
@@ -674,7 +750,7 @@
           <a:lstStyle/>
           <a:p>
             <a:r>
-              <a:t>DeepLabV3+ 우승. Atrous conv로 공간 정보 복원이 병변 경계에 유리. Decoder 교체 &gt; Encoder 경량화.</a:t>
+              <a:t>P4-A2 결과. 초록=정상, 빨강=궤양병. GT와 예측이 거의 겹침.</a:t>
             </a:r>
           </a:p>
         </p:txBody>
@@ -744,7 +820,357 @@
           <a:lstStyle/>
           <a:p>
             <a:r>
+              <a:t>노트북 05에서 실행한 3-panel scatter. ViT-Small이 Pareto-optimal.</a:t>
+            </a:r>
+          </a:p>
+        </p:txBody>
+      </p:sp>
+      <p:sp>
+        <p:nvSpPr>
+          <p:cNvPr id="4" name="Slide Number Placeholder 3"/>
+          <p:cNvSpPr>
+            <a:spLocks noGrp="1"/>
+          </p:cNvSpPr>
+          <p:nvPr>
+            <p:ph type="sldNum" idx="5" sz="quarter"/>
+          </p:nvPr>
+        </p:nvSpPr>
+        <p:spPr/>
+      </p:sp>
+    </p:spTree>
+  </p:cSld>
+  <p:clrMapOvr>
+    <a:masterClrMapping/>
+  </p:clrMapOvr>
+</p:notes>
+</file>
+
+<file path=ppt/notesSlides/notesSlide5.xml><?xml version="1.0" encoding="utf-8"?>
+<p:notes xmlns:a="http://schemas.openxmlformats.org/drawingml/2006/main" xmlns:p="http://schemas.openxmlformats.org/presentationml/2006/main" xmlns:r="http://schemas.openxmlformats.org/officeDocument/2006/relationships">
+  <p:cSld>
+    <p:spTree>
+      <p:nvGrpSpPr>
+        <p:cNvPr id="1" name=""/>
+        <p:cNvGrpSpPr/>
+        <p:nvPr/>
+      </p:nvGrpSpPr>
+      <p:grpSpPr>
+        <a:xfrm>
+          <a:off x="0" y="0"/>
+          <a:ext cx="0" cy="0"/>
+          <a:chOff x="0" y="0"/>
+          <a:chExt cx="0" cy="0"/>
+        </a:xfrm>
+      </p:grpSpPr>
+      <p:sp>
+        <p:nvSpPr>
+          <p:cNvPr id="2" name="Slide Image Placeholder 1"/>
+          <p:cNvSpPr>
+            <a:spLocks noGrp="1"/>
+          </p:cNvSpPr>
+          <p:nvPr>
+            <p:ph type="sldImg" idx="2"/>
+          </p:nvPr>
+        </p:nvSpPr>
+        <p:spPr/>
+      </p:sp>
+      <p:sp>
+        <p:nvSpPr>
+          <p:cNvPr id="3" name="Notes Placeholder 2"/>
+          <p:cNvSpPr>
+            <a:spLocks noGrp="1"/>
+          </p:cNvSpPr>
+          <p:nvPr>
+            <p:ph type="body" idx="3" sz="quarter"/>
+          </p:nvPr>
+        </p:nvSpPr>
+        <p:spPr/>
+        <p:txBody>
+          <a:bodyPr/>
+          <a:lstStyle/>
+          <a:p>
+            <a:r>
+              <a:t>ViT-Small이 정확도 최고 + latency 최저 — Apple MPS에서 Transformer가 기존 CNN보다 빠르게 동작한 흥미로운 발견. MobileNetV3은 throughput 왕 (264 FPS, 4.2M params).</a:t>
+            </a:r>
+          </a:p>
+        </p:txBody>
+      </p:sp>
+      <p:sp>
+        <p:nvSpPr>
+          <p:cNvPr id="4" name="Slide Number Placeholder 3"/>
+          <p:cNvSpPr>
+            <a:spLocks noGrp="1"/>
+          </p:cNvSpPr>
+          <p:nvPr>
+            <p:ph type="sldNum" idx="5" sz="quarter"/>
+          </p:nvPr>
+        </p:nvSpPr>
+        <p:spPr/>
+      </p:sp>
+    </p:spTree>
+  </p:cSld>
+  <p:clrMapOvr>
+    <a:masterClrMapping/>
+  </p:clrMapOvr>
+</p:notes>
+</file>
+
+<file path=ppt/notesSlides/notesSlide6.xml><?xml version="1.0" encoding="utf-8"?>
+<p:notes xmlns:a="http://schemas.openxmlformats.org/drawingml/2006/main" xmlns:p="http://schemas.openxmlformats.org/presentationml/2006/main" xmlns:r="http://schemas.openxmlformats.org/officeDocument/2006/relationships">
+  <p:cSld>
+    <p:spTree>
+      <p:nvGrpSpPr>
+        <p:cNvPr id="1" name=""/>
+        <p:cNvGrpSpPr/>
+        <p:nvPr/>
+      </p:nvGrpSpPr>
+      <p:grpSpPr>
+        <a:xfrm>
+          <a:off x="0" y="0"/>
+          <a:ext cx="0" cy="0"/>
+          <a:chOff x="0" y="0"/>
+          <a:chExt cx="0" cy="0"/>
+        </a:xfrm>
+      </p:grpSpPr>
+      <p:sp>
+        <p:nvSpPr>
+          <p:cNvPr id="2" name="Slide Image Placeholder 1"/>
+          <p:cNvSpPr>
+            <a:spLocks noGrp="1"/>
+          </p:cNvSpPr>
+          <p:nvPr>
+            <p:ph type="sldImg" idx="2"/>
+          </p:nvPr>
+        </p:nvSpPr>
+        <p:spPr/>
+      </p:sp>
+      <p:sp>
+        <p:nvSpPr>
+          <p:cNvPr id="3" name="Notes Placeholder 2"/>
+          <p:cNvSpPr>
+            <a:spLocks noGrp="1"/>
+          </p:cNvSpPr>
+          <p:nvPr>
+            <p:ph type="body" idx="3" sz="quarter"/>
+          </p:nvPr>
+        </p:nvSpPr>
+        <p:spPr/>
+        <p:txBody>
+          <a:bodyPr/>
+          <a:lstStyle/>
+          <a:p>
+            <a:r>
+              <a:t>5 epoch로는 yolov8m이 under-fit. yolov8s가 정확도+속도 균형 최고. yolov8n은 엣지/모바일 유력 (168 FPS).</a:t>
+            </a:r>
+          </a:p>
+        </p:txBody>
+      </p:sp>
+      <p:sp>
+        <p:nvSpPr>
+          <p:cNvPr id="4" name="Slide Number Placeholder 3"/>
+          <p:cNvSpPr>
+            <a:spLocks noGrp="1"/>
+          </p:cNvSpPr>
+          <p:nvPr>
+            <p:ph type="sldNum" idx="5" sz="quarter"/>
+          </p:nvPr>
+        </p:nvSpPr>
+        <p:spPr/>
+      </p:sp>
+    </p:spTree>
+  </p:cSld>
+  <p:clrMapOvr>
+    <a:masterClrMapping/>
+  </p:clrMapOvr>
+</p:notes>
+</file>
+
+<file path=ppt/notesSlides/notesSlide7.xml><?xml version="1.0" encoding="utf-8"?>
+<p:notes xmlns:a="http://schemas.openxmlformats.org/drawingml/2006/main" xmlns:p="http://schemas.openxmlformats.org/presentationml/2006/main" xmlns:r="http://schemas.openxmlformats.org/officeDocument/2006/relationships">
+  <p:cSld>
+    <p:spTree>
+      <p:nvGrpSpPr>
+        <p:cNvPr id="1" name=""/>
+        <p:cNvGrpSpPr/>
+        <p:nvPr/>
+      </p:nvGrpSpPr>
+      <p:grpSpPr>
+        <a:xfrm>
+          <a:off x="0" y="0"/>
+          <a:ext cx="0" cy="0"/>
+          <a:chOff x="0" y="0"/>
+          <a:chExt cx="0" cy="0"/>
+        </a:xfrm>
+      </p:grpSpPr>
+      <p:sp>
+        <p:nvSpPr>
+          <p:cNvPr id="2" name="Slide Image Placeholder 1"/>
+          <p:cNvSpPr>
+            <a:spLocks noGrp="1"/>
+          </p:cNvSpPr>
+          <p:nvPr>
+            <p:ph type="sldImg" idx="2"/>
+          </p:nvPr>
+        </p:nvSpPr>
+        <p:spPr/>
+      </p:sp>
+      <p:sp>
+        <p:nvSpPr>
+          <p:cNvPr id="3" name="Notes Placeholder 2"/>
+          <p:cNvSpPr>
+            <a:spLocks noGrp="1"/>
+          </p:cNvSpPr>
+          <p:nvPr>
+            <p:ph type="body" idx="3" sz="quarter"/>
+          </p:nvPr>
+        </p:nvSpPr>
+        <p:spPr/>
+        <p:txBody>
+          <a:bodyPr/>
+          <a:lstStyle/>
+          <a:p>
+            <a:r>
+              <a:t>DeepLabV3+ 우승. Atrous conv로 공간 정보 복원이 병변 경계에 유리. Decoder 교체 &gt; Encoder 경량화.</a:t>
+            </a:r>
+          </a:p>
+        </p:txBody>
+      </p:sp>
+      <p:sp>
+        <p:nvSpPr>
+          <p:cNvPr id="4" name="Slide Number Placeholder 3"/>
+          <p:cNvSpPr>
+            <a:spLocks noGrp="1"/>
+          </p:cNvSpPr>
+          <p:nvPr>
+            <p:ph type="sldNum" idx="5" sz="quarter"/>
+          </p:nvPr>
+        </p:nvSpPr>
+        <p:spPr/>
+      </p:sp>
+    </p:spTree>
+  </p:cSld>
+  <p:clrMapOvr>
+    <a:masterClrMapping/>
+  </p:clrMapOvr>
+</p:notes>
+</file>
+
+<file path=ppt/notesSlides/notesSlide8.xml><?xml version="1.0" encoding="utf-8"?>
+<p:notes xmlns:a="http://schemas.openxmlformats.org/drawingml/2006/main" xmlns:p="http://schemas.openxmlformats.org/presentationml/2006/main" xmlns:r="http://schemas.openxmlformats.org/officeDocument/2006/relationships">
+  <p:cSld>
+    <p:spTree>
+      <p:nvGrpSpPr>
+        <p:cNvPr id="1" name=""/>
+        <p:cNvGrpSpPr/>
+        <p:nvPr/>
+      </p:nvGrpSpPr>
+      <p:grpSpPr>
+        <a:xfrm>
+          <a:off x="0" y="0"/>
+          <a:ext cx="0" cy="0"/>
+          <a:chOff x="0" y="0"/>
+          <a:chExt cx="0" cy="0"/>
+        </a:xfrm>
+      </p:grpSpPr>
+      <p:sp>
+        <p:nvSpPr>
+          <p:cNvPr id="2" name="Slide Image Placeholder 1"/>
+          <p:cNvSpPr>
+            <a:spLocks noGrp="1"/>
+          </p:cNvSpPr>
+          <p:nvPr>
+            <p:ph type="sldImg" idx="2"/>
+          </p:nvPr>
+        </p:nvSpPr>
+        <p:spPr/>
+      </p:sp>
+      <p:sp>
+        <p:nvSpPr>
+          <p:cNvPr id="3" name="Notes Placeholder 2"/>
+          <p:cNvSpPr>
+            <a:spLocks noGrp="1"/>
+          </p:cNvSpPr>
+          <p:nvPr>
+            <p:ph type="body" idx="3" sz="quarter"/>
+          </p:nvPr>
+        </p:nvSpPr>
+        <p:spPr/>
+        <p:txBody>
+          <a:bodyPr/>
+          <a:lstStyle/>
+          <a:p>
+            <a:r>
               <a:t>크기 73% 축소 + 정확도 완전 보존. 그러나 CPU에서 dynamic quant 오버헤드로 latency 오히려 증가. 교훈: 양자화 ≠ 항상 빠름. 크기 제약 환경에서 유용.</a:t>
+            </a:r>
+          </a:p>
+        </p:txBody>
+      </p:sp>
+      <p:sp>
+        <p:nvSpPr>
+          <p:cNvPr id="4" name="Slide Number Placeholder 3"/>
+          <p:cNvSpPr>
+            <a:spLocks noGrp="1"/>
+          </p:cNvSpPr>
+          <p:nvPr>
+            <p:ph type="sldNum" idx="5" sz="quarter"/>
+          </p:nvPr>
+        </p:nvSpPr>
+        <p:spPr/>
+      </p:sp>
+    </p:spTree>
+  </p:cSld>
+  <p:clrMapOvr>
+    <a:masterClrMapping/>
+  </p:clrMapOvr>
+</p:notes>
+</file>
+
+<file path=ppt/notesSlides/notesSlide9.xml><?xml version="1.0" encoding="utf-8"?>
+<p:notes xmlns:a="http://schemas.openxmlformats.org/drawingml/2006/main" xmlns:p="http://schemas.openxmlformats.org/presentationml/2006/main" xmlns:r="http://schemas.openxmlformats.org/officeDocument/2006/relationships">
+  <p:cSld>
+    <p:spTree>
+      <p:nvGrpSpPr>
+        <p:cNvPr id="1" name=""/>
+        <p:cNvGrpSpPr/>
+        <p:nvPr/>
+      </p:nvGrpSpPr>
+      <p:grpSpPr>
+        <a:xfrm>
+          <a:off x="0" y="0"/>
+          <a:ext cx="0" cy="0"/>
+          <a:chOff x="0" y="0"/>
+          <a:chExt cx="0" cy="0"/>
+        </a:xfrm>
+      </p:grpSpPr>
+      <p:sp>
+        <p:nvSpPr>
+          <p:cNvPr id="2" name="Slide Image Placeholder 1"/>
+          <p:cNvSpPr>
+            <a:spLocks noGrp="1"/>
+          </p:cNvSpPr>
+          <p:nvPr>
+            <p:ph type="sldImg" idx="2"/>
+          </p:nvPr>
+        </p:nvSpPr>
+        <p:spPr/>
+      </p:sp>
+      <p:sp>
+        <p:nvSpPr>
+          <p:cNvPr id="3" name="Notes Placeholder 2"/>
+          <p:cNvSpPr>
+            <a:spLocks noGrp="1"/>
+          </p:cNvSpPr>
+          <p:nvPr>
+            <p:ph type="body" idx="3" sz="quarter"/>
+          </p:nvPr>
+        </p:nvSpPr>
+        <p:spPr/>
+        <p:txBody>
+          <a:bodyPr/>
+          <a:lstStyle/>
+          <a:p>
+            <a:r>
+              <a:t>ResNet50이 정상 샘플에서 과일 중앙~표면 텍스처에 집중하는 패턴.</a:t>
             </a:r>
           </a:p>
         </p:txBody>
@@ -4014,6 +4440,160 @@
           <a:lstStyle/>
           <a:p>
             <a:r>
+              <a:rPr sz="2600" b="1">
+                <a:solidFill>
+                  <a:srgbClr val="165B33"/>
+                </a:solidFill>
+                <a:latin typeface="Malgun Gothic"/>
+              </a:rPr>
+              <a:t>결과 이미지 — ViT-Small Confusion Matrix</a:t>
+            </a:r>
+          </a:p>
+        </p:txBody>
+      </p:sp>
+      <p:sp>
+        <p:nvSpPr>
+          <p:cNvPr id="3" name="Rectangle 2"/>
+          <p:cNvSpPr/>
+          <p:nvPr/>
+        </p:nvSpPr>
+        <p:spPr>
+          <a:xfrm>
+            <a:off x="457200" y="1005840"/>
+            <a:ext cx="1371600" cy="38100"/>
+          </a:xfrm>
+          <a:prstGeom prst="rect">
+            <a:avLst/>
+          </a:prstGeom>
+          <a:solidFill>
+            <a:srgbClr val="E87200"/>
+          </a:solidFill>
+          <a:ln>
+            <a:noFill/>
+          </a:ln>
+        </p:spPr>
+        <p:style>
+          <a:lnRef idx="1">
+            <a:schemeClr val="accent1"/>
+          </a:lnRef>
+          <a:fillRef idx="3">
+            <a:schemeClr val="accent1"/>
+          </a:fillRef>
+          <a:effectRef idx="2">
+            <a:schemeClr val="accent1"/>
+          </a:effectRef>
+          <a:fontRef idx="minor">
+            <a:schemeClr val="lt1"/>
+          </a:fontRef>
+        </p:style>
+        <p:txBody>
+          <a:bodyPr rtlCol="0" anchor="ctr"/>
+          <a:lstStyle/>
+          <a:p>
+            <a:pPr algn="ctr"/>
+          </a:p>
+        </p:txBody>
+      </p:sp>
+      <p:pic>
+        <p:nvPicPr>
+          <p:cNvPr id="4" name="Picture 3" descr="cls_vit_cm.png"/>
+          <p:cNvPicPr>
+            <a:picLocks noChangeAspect="1"/>
+          </p:cNvPicPr>
+          <p:nvPr/>
+        </p:nvPicPr>
+        <p:blipFill>
+          <a:blip r:embed="rId2"/>
+          <a:stretch>
+            <a:fillRect/>
+          </a:stretch>
+        </p:blipFill>
+        <p:spPr>
+          <a:xfrm>
+            <a:off x="2952598" y="1280160"/>
+            <a:ext cx="6286499" cy="5029200"/>
+          </a:xfrm>
+          <a:prstGeom prst="rect">
+            <a:avLst/>
+          </a:prstGeom>
+        </p:spPr>
+      </p:pic>
+      <p:sp>
+        <p:nvSpPr>
+          <p:cNvPr id="5" name="TextBox 4"/>
+          <p:cNvSpPr txBox="1"/>
+          <p:nvPr/>
+        </p:nvSpPr>
+        <p:spPr>
+          <a:xfrm>
+            <a:off x="457200" y="6400800"/>
+            <a:ext cx="11277295" cy="274320"/>
+          </a:xfrm>
+          <a:prstGeom prst="rect">
+            <a:avLst/>
+          </a:prstGeom>
+          <a:noFill/>
+        </p:spPr>
+        <p:txBody>
+          <a:bodyPr wrap="square">
+            <a:spAutoFit/>
+          </a:bodyPr>
+          <a:lstStyle/>
+          <a:p>
+            <a:pPr algn="ctr"/>
+            <a:r>
+              <a:rPr sz="1200" b="0" i="1">
+                <a:solidFill>
+                  <a:srgbClr val="555555"/>
+                </a:solidFill>
+                <a:latin typeface="Malgun Gothic"/>
+              </a:rPr>
+              <a:t>ViT-Small/16 on val set (427) — 오분류 4장 (FN 1, FP 3)</a:t>
+            </a:r>
+          </a:p>
+        </p:txBody>
+      </p:sp>
+    </p:spTree>
+  </p:cSld>
+  <p:clrMapOvr>
+    <a:masterClrMapping/>
+  </p:clrMapOvr>
+</p:sld>
+</file>
+
+<file path=ppt/slides/slide11.xml><?xml version="1.0" encoding="utf-8"?>
+<p:sld xmlns:a="http://schemas.openxmlformats.org/drawingml/2006/main" xmlns:p="http://schemas.openxmlformats.org/presentationml/2006/main" xmlns:r="http://schemas.openxmlformats.org/officeDocument/2006/relationships">
+  <p:cSld>
+    <p:spTree>
+      <p:nvGrpSpPr>
+        <p:cNvPr id="1" name=""/>
+        <p:cNvGrpSpPr/>
+        <p:nvPr/>
+      </p:nvGrpSpPr>
+      <p:grpSpPr/>
+      <p:sp>
+        <p:nvSpPr>
+          <p:cNvPr id="2" name="TextBox 1"/>
+          <p:cNvSpPr txBox="1"/>
+          <p:nvPr/>
+        </p:nvSpPr>
+        <p:spPr>
+          <a:xfrm>
+            <a:off x="457200" y="274320"/>
+            <a:ext cx="11277295" cy="822960"/>
+          </a:xfrm>
+          <a:prstGeom prst="rect">
+            <a:avLst/>
+          </a:prstGeom>
+          <a:noFill/>
+        </p:spPr>
+        <p:txBody>
+          <a:bodyPr wrap="square">
+            <a:spAutoFit/>
+          </a:bodyPr>
+          <a:lstStyle/>
+          <a:p>
+            <a:r>
               <a:rPr sz="2800" b="1">
                 <a:solidFill>
                   <a:srgbClr val="165B33"/>
@@ -4243,7 +4823,220 @@
 </p:sld>
 </file>
 
-<file path=ppt/slides/slide11.xml><?xml version="1.0" encoding="utf-8"?>
+<file path=ppt/slides/slide12.xml><?xml version="1.0" encoding="utf-8"?>
+<p:sld xmlns:a="http://schemas.openxmlformats.org/drawingml/2006/main" xmlns:p="http://schemas.openxmlformats.org/presentationml/2006/main" xmlns:r="http://schemas.openxmlformats.org/officeDocument/2006/relationships">
+  <p:cSld>
+    <p:spTree>
+      <p:nvGrpSpPr>
+        <p:cNvPr id="1" name=""/>
+        <p:cNvGrpSpPr/>
+        <p:nvPr/>
+      </p:nvGrpSpPr>
+      <p:grpSpPr/>
+      <p:sp>
+        <p:nvSpPr>
+          <p:cNvPr id="2" name="TextBox 1"/>
+          <p:cNvSpPr txBox="1"/>
+          <p:nvPr/>
+        </p:nvSpPr>
+        <p:spPr>
+          <a:xfrm>
+            <a:off x="457200" y="274320"/>
+            <a:ext cx="11277295" cy="822960"/>
+          </a:xfrm>
+          <a:prstGeom prst="rect">
+            <a:avLst/>
+          </a:prstGeom>
+          <a:noFill/>
+        </p:spPr>
+        <p:txBody>
+          <a:bodyPr wrap="square">
+            <a:spAutoFit/>
+          </a:bodyPr>
+          <a:lstStyle/>
+          <a:p>
+            <a:r>
+              <a:rPr sz="2600" b="1">
+                <a:solidFill>
+                  <a:srgbClr val="165B33"/>
+                </a:solidFill>
+                <a:latin typeface="Malgun Gothic"/>
+              </a:rPr>
+              <a:t>결과 이미지 — YOLOv8m 30ep 학습 곡선 &amp; Confusion Matrix</a:t>
+            </a:r>
+          </a:p>
+        </p:txBody>
+      </p:sp>
+      <p:sp>
+        <p:nvSpPr>
+          <p:cNvPr id="3" name="Rectangle 2"/>
+          <p:cNvSpPr/>
+          <p:nvPr/>
+        </p:nvSpPr>
+        <p:spPr>
+          <a:xfrm>
+            <a:off x="457200" y="1005840"/>
+            <a:ext cx="1371600" cy="38100"/>
+          </a:xfrm>
+          <a:prstGeom prst="rect">
+            <a:avLst/>
+          </a:prstGeom>
+          <a:solidFill>
+            <a:srgbClr val="E87200"/>
+          </a:solidFill>
+          <a:ln>
+            <a:noFill/>
+          </a:ln>
+        </p:spPr>
+        <p:style>
+          <a:lnRef idx="1">
+            <a:schemeClr val="accent1"/>
+          </a:lnRef>
+          <a:fillRef idx="3">
+            <a:schemeClr val="accent1"/>
+          </a:fillRef>
+          <a:effectRef idx="2">
+            <a:schemeClr val="accent1"/>
+          </a:effectRef>
+          <a:fontRef idx="minor">
+            <a:schemeClr val="lt1"/>
+          </a:fontRef>
+        </p:style>
+        <p:txBody>
+          <a:bodyPr rtlCol="0" anchor="ctr"/>
+          <a:lstStyle/>
+          <a:p>
+            <a:pPr algn="ctr"/>
+          </a:p>
+        </p:txBody>
+      </p:sp>
+      <p:pic>
+        <p:nvPicPr>
+          <p:cNvPr id="4" name="Picture 3" descr="det_yolov8m_training.png"/>
+          <p:cNvPicPr>
+            <a:picLocks noChangeAspect="1"/>
+          </p:cNvPicPr>
+          <p:nvPr/>
+        </p:nvPicPr>
+        <p:blipFill>
+          <a:blip r:embed="rId2"/>
+          <a:stretch>
+            <a:fillRect/>
+          </a:stretch>
+        </p:blipFill>
+        <p:spPr>
+          <a:xfrm>
+            <a:off x="457200" y="1280160"/>
+            <a:ext cx="5501487" cy="2750744"/>
+          </a:xfrm>
+          <a:prstGeom prst="rect">
+            <a:avLst/>
+          </a:prstGeom>
+        </p:spPr>
+      </p:pic>
+      <p:sp>
+        <p:nvSpPr>
+          <p:cNvPr id="5" name="TextBox 4"/>
+          <p:cNvSpPr txBox="1"/>
+          <p:nvPr/>
+        </p:nvSpPr>
+        <p:spPr>
+          <a:xfrm>
+            <a:off x="457200" y="4122344"/>
+            <a:ext cx="5501487" cy="274320"/>
+          </a:xfrm>
+          <a:prstGeom prst="rect">
+            <a:avLst/>
+          </a:prstGeom>
+          <a:noFill/>
+        </p:spPr>
+        <p:txBody>
+          <a:bodyPr wrap="square">
+            <a:spAutoFit/>
+          </a:bodyPr>
+          <a:lstStyle/>
+          <a:p>
+            <a:pPr algn="ctr"/>
+            <a:r>
+              <a:rPr sz="1100" b="0" i="1">
+                <a:solidFill>
+                  <a:srgbClr val="555555"/>
+                </a:solidFill>
+                <a:latin typeface="Malgun Gothic"/>
+              </a:rPr>
+              <a:t>Training curves (loss &amp; mAP over 30 epochs)</a:t>
+            </a:r>
+          </a:p>
+        </p:txBody>
+      </p:sp>
+      <p:pic>
+        <p:nvPicPr>
+          <p:cNvPr id="6" name="Picture 5" descr="det_yolov8m_cm.png"/>
+          <p:cNvPicPr>
+            <a:picLocks noChangeAspect="1"/>
+          </p:cNvPicPr>
+          <p:nvPr/>
+        </p:nvPicPr>
+        <p:blipFill>
+          <a:blip r:embed="rId3"/>
+          <a:stretch>
+            <a:fillRect/>
+          </a:stretch>
+        </p:blipFill>
+        <p:spPr>
+          <a:xfrm>
+            <a:off x="6233007" y="1280160"/>
+            <a:ext cx="5501487" cy="4126115"/>
+          </a:xfrm>
+          <a:prstGeom prst="rect">
+            <a:avLst/>
+          </a:prstGeom>
+        </p:spPr>
+      </p:pic>
+      <p:sp>
+        <p:nvSpPr>
+          <p:cNvPr id="7" name="TextBox 6"/>
+          <p:cNvSpPr txBox="1"/>
+          <p:nvPr/>
+        </p:nvSpPr>
+        <p:spPr>
+          <a:xfrm>
+            <a:off x="6233007" y="5497715"/>
+            <a:ext cx="5501487" cy="274320"/>
+          </a:xfrm>
+          <a:prstGeom prst="rect">
+            <a:avLst/>
+          </a:prstGeom>
+          <a:noFill/>
+        </p:spPr>
+        <p:txBody>
+          <a:bodyPr wrap="square">
+            <a:spAutoFit/>
+          </a:bodyPr>
+          <a:lstStyle/>
+          <a:p>
+            <a:pPr algn="ctr"/>
+            <a:r>
+              <a:rPr sz="1100" b="0" i="1">
+                <a:solidFill>
+                  <a:srgbClr val="555555"/>
+                </a:solidFill>
+                <a:latin typeface="Malgun Gothic"/>
+              </a:rPr>
+              <a:t>Confusion matrix (val 88 images)</a:t>
+            </a:r>
+          </a:p>
+        </p:txBody>
+      </p:sp>
+    </p:spTree>
+  </p:cSld>
+  <p:clrMapOvr>
+    <a:masterClrMapping/>
+  </p:clrMapOvr>
+</p:sld>
+</file>
+
+<file path=ppt/slides/slide13.xml><?xml version="1.0" encoding="utf-8"?>
 <p:sld xmlns:a="http://schemas.openxmlformats.org/drawingml/2006/main" xmlns:p="http://schemas.openxmlformats.org/presentationml/2006/main" xmlns:r="http://schemas.openxmlformats.org/officeDocument/2006/relationships">
   <p:cSld>
     <p:spTree>
@@ -4505,7 +5298,220 @@
 </p:sld>
 </file>
 
-<file path=ppt/slides/slide12.xml><?xml version="1.0" encoding="utf-8"?>
+<file path=ppt/slides/slide14.xml><?xml version="1.0" encoding="utf-8"?>
+<p:sld xmlns:a="http://schemas.openxmlformats.org/drawingml/2006/main" xmlns:p="http://schemas.openxmlformats.org/presentationml/2006/main" xmlns:r="http://schemas.openxmlformats.org/officeDocument/2006/relationships">
+  <p:cSld>
+    <p:spTree>
+      <p:nvGrpSpPr>
+        <p:cNvPr id="1" name=""/>
+        <p:cNvGrpSpPr/>
+        <p:nvPr/>
+      </p:nvGrpSpPr>
+      <p:grpSpPr/>
+      <p:sp>
+        <p:nvSpPr>
+          <p:cNvPr id="2" name="TextBox 1"/>
+          <p:cNvSpPr txBox="1"/>
+          <p:nvPr/>
+        </p:nvSpPr>
+        <p:spPr>
+          <a:xfrm>
+            <a:off x="457200" y="274320"/>
+            <a:ext cx="11277295" cy="822960"/>
+          </a:xfrm>
+          <a:prstGeom prst="rect">
+            <a:avLst/>
+          </a:prstGeom>
+          <a:noFill/>
+        </p:spPr>
+        <p:txBody>
+          <a:bodyPr wrap="square">
+            <a:spAutoFit/>
+          </a:bodyPr>
+          <a:lstStyle/>
+          <a:p>
+            <a:r>
+              <a:rPr sz="2600" b="1">
+                <a:solidFill>
+                  <a:srgbClr val="165B33"/>
+                </a:solidFill>
+                <a:latin typeface="Malgun Gothic"/>
+              </a:rPr>
+              <a:t>결과 이미지 — Segmentation 정성 샘플 (DeepLabV3+ 20ep)</a:t>
+            </a:r>
+          </a:p>
+        </p:txBody>
+      </p:sp>
+      <p:sp>
+        <p:nvSpPr>
+          <p:cNvPr id="3" name="Rectangle 2"/>
+          <p:cNvSpPr/>
+          <p:nvPr/>
+        </p:nvSpPr>
+        <p:spPr>
+          <a:xfrm>
+            <a:off x="457200" y="1005840"/>
+            <a:ext cx="1371600" cy="38100"/>
+          </a:xfrm>
+          <a:prstGeom prst="rect">
+            <a:avLst/>
+          </a:prstGeom>
+          <a:solidFill>
+            <a:srgbClr val="E87200"/>
+          </a:solidFill>
+          <a:ln>
+            <a:noFill/>
+          </a:ln>
+        </p:spPr>
+        <p:style>
+          <a:lnRef idx="1">
+            <a:schemeClr val="accent1"/>
+          </a:lnRef>
+          <a:fillRef idx="3">
+            <a:schemeClr val="accent1"/>
+          </a:fillRef>
+          <a:effectRef idx="2">
+            <a:schemeClr val="accent1"/>
+          </a:effectRef>
+          <a:fontRef idx="minor">
+            <a:schemeClr val="lt1"/>
+          </a:fontRef>
+        </p:style>
+        <p:txBody>
+          <a:bodyPr rtlCol="0" anchor="ctr"/>
+          <a:lstStyle/>
+          <a:p>
+            <a:pPr algn="ctr"/>
+          </a:p>
+        </p:txBody>
+      </p:sp>
+      <p:pic>
+        <p:nvPicPr>
+          <p:cNvPr id="4" name="Picture 3" descr="seg_sample_000.png"/>
+          <p:cNvPicPr>
+            <a:picLocks noChangeAspect="1"/>
+          </p:cNvPicPr>
+          <p:nvPr/>
+        </p:nvPicPr>
+        <p:blipFill>
+          <a:blip r:embed="rId2"/>
+          <a:stretch>
+            <a:fillRect/>
+          </a:stretch>
+        </p:blipFill>
+        <p:spPr>
+          <a:xfrm>
+            <a:off x="457200" y="1280160"/>
+            <a:ext cx="5501487" cy="1833829"/>
+          </a:xfrm>
+          <a:prstGeom prst="rect">
+            <a:avLst/>
+          </a:prstGeom>
+        </p:spPr>
+      </p:pic>
+      <p:sp>
+        <p:nvSpPr>
+          <p:cNvPr id="5" name="TextBox 4"/>
+          <p:cNvSpPr txBox="1"/>
+          <p:nvPr/>
+        </p:nvSpPr>
+        <p:spPr>
+          <a:xfrm>
+            <a:off x="457200" y="3205429"/>
+            <a:ext cx="5501487" cy="274320"/>
+          </a:xfrm>
+          <a:prstGeom prst="rect">
+            <a:avLst/>
+          </a:prstGeom>
+          <a:noFill/>
+        </p:spPr>
+        <p:txBody>
+          <a:bodyPr wrap="square">
+            <a:spAutoFit/>
+          </a:bodyPr>
+          <a:lstStyle/>
+          <a:p>
+            <a:pPr algn="ctr"/>
+            <a:r>
+              <a:rPr sz="1100" b="0" i="1">
+                <a:solidFill>
+                  <a:srgbClr val="555555"/>
+                </a:solidFill>
+                <a:latin typeface="Malgun Gothic"/>
+              </a:rPr>
+              <a:t>샘플 #1 (원본 | GT mask | 예측 mask)</a:t>
+            </a:r>
+          </a:p>
+        </p:txBody>
+      </p:sp>
+      <p:pic>
+        <p:nvPicPr>
+          <p:cNvPr id="6" name="Picture 5" descr="seg_sample_001.png"/>
+          <p:cNvPicPr>
+            <a:picLocks noChangeAspect="1"/>
+          </p:cNvPicPr>
+          <p:nvPr/>
+        </p:nvPicPr>
+        <p:blipFill>
+          <a:blip r:embed="rId3"/>
+          <a:stretch>
+            <a:fillRect/>
+          </a:stretch>
+        </p:blipFill>
+        <p:spPr>
+          <a:xfrm>
+            <a:off x="6233007" y="1280160"/>
+            <a:ext cx="5501487" cy="1833829"/>
+          </a:xfrm>
+          <a:prstGeom prst="rect">
+            <a:avLst/>
+          </a:prstGeom>
+        </p:spPr>
+      </p:pic>
+      <p:sp>
+        <p:nvSpPr>
+          <p:cNvPr id="7" name="TextBox 6"/>
+          <p:cNvSpPr txBox="1"/>
+          <p:nvPr/>
+        </p:nvSpPr>
+        <p:spPr>
+          <a:xfrm>
+            <a:off x="6233007" y="3205429"/>
+            <a:ext cx="5501487" cy="274320"/>
+          </a:xfrm>
+          <a:prstGeom prst="rect">
+            <a:avLst/>
+          </a:prstGeom>
+          <a:noFill/>
+        </p:spPr>
+        <p:txBody>
+          <a:bodyPr wrap="square">
+            <a:spAutoFit/>
+          </a:bodyPr>
+          <a:lstStyle/>
+          <a:p>
+            <a:pPr algn="ctr"/>
+            <a:r>
+              <a:rPr sz="1100" b="0" i="1">
+                <a:solidFill>
+                  <a:srgbClr val="555555"/>
+                </a:solidFill>
+                <a:latin typeface="Malgun Gothic"/>
+              </a:rPr>
+              <a:t>샘플 #2 (원본 | GT mask | 예측 mask)</a:t>
+            </a:r>
+          </a:p>
+        </p:txBody>
+      </p:sp>
+    </p:spTree>
+  </p:cSld>
+  <p:clrMapOvr>
+    <a:masterClrMapping/>
+  </p:clrMapOvr>
+</p:sld>
+</file>
+
+<file path=ppt/slides/slide15.xml><?xml version="1.0" encoding="utf-8"?>
 <p:sld xmlns:a="http://schemas.openxmlformats.org/drawingml/2006/main" xmlns:p="http://schemas.openxmlformats.org/presentationml/2006/main" xmlns:r="http://schemas.openxmlformats.org/officeDocument/2006/relationships">
   <p:cSld>
     <p:spTree>
@@ -4767,7 +5773,7 @@
 </p:sld>
 </file>
 
-<file path=ppt/slides/slide13.xml><?xml version="1.0" encoding="utf-8"?>
+<file path=ppt/slides/slide16.xml><?xml version="1.0" encoding="utf-8"?>
 <p:sld xmlns:a="http://schemas.openxmlformats.org/drawingml/2006/main" xmlns:p="http://schemas.openxmlformats.org/presentationml/2006/main" xmlns:r="http://schemas.openxmlformats.org/officeDocument/2006/relationships">
   <p:cSld>
     <p:spTree>
@@ -4873,7 +5879,161 @@
 </p:sld>
 </file>
 
-<file path=ppt/slides/slide14.xml><?xml version="1.0" encoding="utf-8"?>
+<file path=ppt/slides/slide17.xml><?xml version="1.0" encoding="utf-8"?>
+<p:sld xmlns:a="http://schemas.openxmlformats.org/drawingml/2006/main" xmlns:p="http://schemas.openxmlformats.org/presentationml/2006/main" xmlns:r="http://schemas.openxmlformats.org/officeDocument/2006/relationships">
+  <p:cSld>
+    <p:spTree>
+      <p:nvGrpSpPr>
+        <p:cNvPr id="1" name=""/>
+        <p:cNvGrpSpPr/>
+        <p:nvPr/>
+      </p:nvGrpSpPr>
+      <p:grpSpPr/>
+      <p:sp>
+        <p:nvSpPr>
+          <p:cNvPr id="2" name="TextBox 1"/>
+          <p:cNvSpPr txBox="1"/>
+          <p:nvPr/>
+        </p:nvSpPr>
+        <p:spPr>
+          <a:xfrm>
+            <a:off x="457200" y="274320"/>
+            <a:ext cx="11277295" cy="822960"/>
+          </a:xfrm>
+          <a:prstGeom prst="rect">
+            <a:avLst/>
+          </a:prstGeom>
+          <a:noFill/>
+        </p:spPr>
+        <p:txBody>
+          <a:bodyPr wrap="square">
+            <a:spAutoFit/>
+          </a:bodyPr>
+          <a:lstStyle/>
+          <a:p>
+            <a:r>
+              <a:rPr sz="2600" b="1">
+                <a:solidFill>
+                  <a:srgbClr val="165B33"/>
+                </a:solidFill>
+                <a:latin typeface="Malgun Gothic"/>
+              </a:rPr>
+              <a:t>결과 이미지 — P1b 백본 비교 시각화</a:t>
+            </a:r>
+          </a:p>
+        </p:txBody>
+      </p:sp>
+      <p:sp>
+        <p:nvSpPr>
+          <p:cNvPr id="3" name="Rectangle 2"/>
+          <p:cNvSpPr/>
+          <p:nvPr/>
+        </p:nvSpPr>
+        <p:spPr>
+          <a:xfrm>
+            <a:off x="457200" y="1005840"/>
+            <a:ext cx="1371600" cy="38100"/>
+          </a:xfrm>
+          <a:prstGeom prst="rect">
+            <a:avLst/>
+          </a:prstGeom>
+          <a:solidFill>
+            <a:srgbClr val="E87200"/>
+          </a:solidFill>
+          <a:ln>
+            <a:noFill/>
+          </a:ln>
+        </p:spPr>
+        <p:style>
+          <a:lnRef idx="1">
+            <a:schemeClr val="accent1"/>
+          </a:lnRef>
+          <a:fillRef idx="3">
+            <a:schemeClr val="accent1"/>
+          </a:fillRef>
+          <a:effectRef idx="2">
+            <a:schemeClr val="accent1"/>
+          </a:effectRef>
+          <a:fontRef idx="minor">
+            <a:schemeClr val="lt1"/>
+          </a:fontRef>
+        </p:style>
+        <p:txBody>
+          <a:bodyPr rtlCol="0" anchor="ctr"/>
+          <a:lstStyle/>
+          <a:p>
+            <a:pPr algn="ctr"/>
+          </a:p>
+        </p:txBody>
+      </p:sp>
+      <p:pic>
+        <p:nvPicPr>
+          <p:cNvPr id="4" name="Picture 3" descr="nb05_fig_02.png"/>
+          <p:cNvPicPr>
+            <a:picLocks noChangeAspect="1"/>
+          </p:cNvPicPr>
+          <p:nvPr/>
+        </p:nvPicPr>
+        <p:blipFill>
+          <a:blip r:embed="rId2"/>
+          <a:stretch>
+            <a:fillRect/>
+          </a:stretch>
+        </p:blipFill>
+        <p:spPr>
+          <a:xfrm>
+            <a:off x="457200" y="1280160"/>
+            <a:ext cx="11277295" cy="3248214"/>
+          </a:xfrm>
+          <a:prstGeom prst="rect">
+            <a:avLst/>
+          </a:prstGeom>
+        </p:spPr>
+      </p:pic>
+      <p:sp>
+        <p:nvSpPr>
+          <p:cNvPr id="5" name="TextBox 4"/>
+          <p:cNvSpPr txBox="1"/>
+          <p:nvPr/>
+        </p:nvSpPr>
+        <p:spPr>
+          <a:xfrm>
+            <a:off x="457200" y="4619814"/>
+            <a:ext cx="11277295" cy="274320"/>
+          </a:xfrm>
+          <a:prstGeom prst="rect">
+            <a:avLst/>
+          </a:prstGeom>
+          <a:noFill/>
+        </p:spPr>
+        <p:txBody>
+          <a:bodyPr wrap="square">
+            <a:spAutoFit/>
+          </a:bodyPr>
+          <a:lstStyle/>
+          <a:p>
+            <a:pPr algn="ctr"/>
+            <a:r>
+              <a:rPr sz="1200" b="0" i="1">
+                <a:solidFill>
+                  <a:srgbClr val="555555"/>
+                </a:solidFill>
+                <a:latin typeface="Malgun Gothic"/>
+              </a:rPr>
+              <a:t>scatter: params vs accuracy / latency vs F1 / throughput vs accuracy</a:t>
+            </a:r>
+          </a:p>
+        </p:txBody>
+      </p:sp>
+    </p:spTree>
+  </p:cSld>
+  <p:clrMapOvr>
+    <a:masterClrMapping/>
+  </p:clrMapOvr>
+</p:sld>
+</file>
+
+<file path=ppt/slides/slide18.xml><?xml version="1.0" encoding="utf-8"?>
 <p:sld xmlns:a="http://schemas.openxmlformats.org/drawingml/2006/main" xmlns:p="http://schemas.openxmlformats.org/presentationml/2006/main" xmlns:r="http://schemas.openxmlformats.org/officeDocument/2006/relationships">
   <p:cSld>
     <p:spTree>
@@ -5838,7 +6998,7 @@
 </p:sld>
 </file>
 
-<file path=ppt/slides/slide15.xml><?xml version="1.0" encoding="utf-8"?>
+<file path=ppt/slides/slide19.xml><?xml version="1.0" encoding="utf-8"?>
 <p:sld xmlns:a="http://schemas.openxmlformats.org/drawingml/2006/main" xmlns:p="http://schemas.openxmlformats.org/presentationml/2006/main" xmlns:r="http://schemas.openxmlformats.org/officeDocument/2006/relationships">
   <p:cSld>
     <p:spTree>
@@ -6523,7 +7683,269 @@
 </p:sld>
 </file>
 
-<file path=ppt/slides/slide16.xml><?xml version="1.0" encoding="utf-8"?>
+<file path=ppt/slides/slide2.xml><?xml version="1.0" encoding="utf-8"?>
+<p:sld xmlns:a="http://schemas.openxmlformats.org/drawingml/2006/main" xmlns:p="http://schemas.openxmlformats.org/presentationml/2006/main" xmlns:r="http://schemas.openxmlformats.org/officeDocument/2006/relationships">
+  <p:cSld>
+    <p:spTree>
+      <p:nvGrpSpPr>
+        <p:cNvPr id="1" name=""/>
+        <p:cNvGrpSpPr/>
+        <p:nvPr/>
+      </p:nvGrpSpPr>
+      <p:grpSpPr/>
+      <p:sp>
+        <p:nvSpPr>
+          <p:cNvPr id="2" name="TextBox 1"/>
+          <p:cNvSpPr txBox="1"/>
+          <p:nvPr/>
+        </p:nvSpPr>
+        <p:spPr>
+          <a:xfrm>
+            <a:off x="457200" y="274320"/>
+            <a:ext cx="11277295" cy="822960"/>
+          </a:xfrm>
+          <a:prstGeom prst="rect">
+            <a:avLst/>
+          </a:prstGeom>
+          <a:noFill/>
+        </p:spPr>
+        <p:txBody>
+          <a:bodyPr wrap="square">
+            <a:spAutoFit/>
+          </a:bodyPr>
+          <a:lstStyle/>
+          <a:p>
+            <a:r>
+              <a:rPr sz="2800" b="1">
+                <a:solidFill>
+                  <a:srgbClr val="165B33"/>
+                </a:solidFill>
+                <a:latin typeface="Malgun Gothic"/>
+              </a:rPr>
+              <a:t>목차</a:t>
+            </a:r>
+          </a:p>
+        </p:txBody>
+      </p:sp>
+      <p:sp>
+        <p:nvSpPr>
+          <p:cNvPr id="3" name="Rectangle 2"/>
+          <p:cNvSpPr/>
+          <p:nvPr/>
+        </p:nvSpPr>
+        <p:spPr>
+          <a:xfrm>
+            <a:off x="457200" y="1051560"/>
+            <a:ext cx="1371600" cy="38100"/>
+          </a:xfrm>
+          <a:prstGeom prst="rect">
+            <a:avLst/>
+          </a:prstGeom>
+          <a:solidFill>
+            <a:srgbClr val="E87200"/>
+          </a:solidFill>
+          <a:ln>
+            <a:noFill/>
+          </a:ln>
+        </p:spPr>
+        <p:style>
+          <a:lnRef idx="1">
+            <a:schemeClr val="accent1"/>
+          </a:lnRef>
+          <a:fillRef idx="3">
+            <a:schemeClr val="accent1"/>
+          </a:fillRef>
+          <a:effectRef idx="2">
+            <a:schemeClr val="accent1"/>
+          </a:effectRef>
+          <a:fontRef idx="minor">
+            <a:schemeClr val="lt1"/>
+          </a:fontRef>
+        </p:style>
+        <p:txBody>
+          <a:bodyPr rtlCol="0" anchor="ctr"/>
+          <a:lstStyle/>
+          <a:p>
+            <a:pPr algn="ctr"/>
+          </a:p>
+        </p:txBody>
+      </p:sp>
+      <p:sp>
+        <p:nvSpPr>
+          <p:cNvPr id="4" name="TextBox 3"/>
+          <p:cNvSpPr txBox="1"/>
+          <p:nvPr/>
+        </p:nvSpPr>
+        <p:spPr>
+          <a:xfrm>
+            <a:off x="457200" y="1280160"/>
+            <a:ext cx="11277295" cy="5303520"/>
+          </a:xfrm>
+          <a:prstGeom prst="rect">
+            <a:avLst/>
+          </a:prstGeom>
+          <a:noFill/>
+        </p:spPr>
+        <p:txBody>
+          <a:bodyPr wrap="square">
+            <a:spAutoFit/>
+          </a:bodyPr>
+          <a:lstStyle/>
+          <a:p>
+            <a:pPr>
+              <a:spcAft>
+                <a:spcPts val="600"/>
+              </a:spcAft>
+            </a:pPr>
+            <a:r>
+              <a:rPr sz="1800" b="0">
+                <a:solidFill>
+                  <a:srgbClr val="1F1F1F"/>
+                </a:solidFill>
+                <a:latin typeface="Malgun Gothic"/>
+              </a:rPr>
+              <a:t>•  1. 프로젝트 개요 (목적 · 데이터)</a:t>
+            </a:r>
+          </a:p>
+          <a:p>
+            <a:pPr>
+              <a:spcAft>
+                <a:spcPts val="600"/>
+              </a:spcAft>
+            </a:pPr>
+            <a:r>
+              <a:rPr sz="1800" b="0">
+                <a:solidFill>
+                  <a:srgbClr val="1F1F1F"/>
+                </a:solidFill>
+                <a:latin typeface="Malgun Gothic"/>
+              </a:rPr>
+              <a:t>•  2. 아키텍처 &amp; 파이프라인 설계</a:t>
+            </a:r>
+          </a:p>
+          <a:p>
+            <a:pPr>
+              <a:spcAft>
+                <a:spcPts val="600"/>
+              </a:spcAft>
+            </a:pPr>
+            <a:r>
+              <a:rPr sz="1800" b="0">
+                <a:solidFill>
+                  <a:srgbClr val="1F1F1F"/>
+                </a:solidFill>
+                <a:latin typeface="Malgun Gothic"/>
+              </a:rPr>
+              <a:t>•  3. 3가지 CV 태스크 구현</a:t>
+            </a:r>
+          </a:p>
+          <a:p>
+            <a:pPr lvl="1">
+              <a:spcAft>
+                <a:spcPts val="600"/>
+              </a:spcAft>
+            </a:pPr>
+            <a:r>
+              <a:rPr sz="1500" b="0">
+                <a:solidFill>
+                  <a:srgbClr val="555555"/>
+                </a:solidFill>
+                <a:latin typeface="Malgun Gothic"/>
+              </a:rPr>
+              <a:t>    –  P1 Classification / P2 Detection / P3 Segmentation</a:t>
+            </a:r>
+          </a:p>
+          <a:p>
+            <a:pPr>
+              <a:spcAft>
+                <a:spcPts val="600"/>
+              </a:spcAft>
+            </a:pPr>
+            <a:r>
+              <a:rPr sz="1800" b="0">
+                <a:solidFill>
+                  <a:srgbClr val="1F1F1F"/>
+                </a:solidFill>
+                <a:latin typeface="Malgun Gothic"/>
+              </a:rPr>
+              <a:t>•  4. 비교 실험 3종</a:t>
+            </a:r>
+          </a:p>
+          <a:p>
+            <a:pPr lvl="1">
+              <a:spcAft>
+                <a:spcPts val="600"/>
+              </a:spcAft>
+            </a:pPr>
+            <a:r>
+              <a:rPr sz="1500" b="0">
+                <a:solidFill>
+                  <a:srgbClr val="555555"/>
+                </a:solidFill>
+                <a:latin typeface="Malgun Gothic"/>
+              </a:rPr>
+              <a:t>    –  P1b 백본 / P2b YOLO / P3b Seg 아키텍처</a:t>
+            </a:r>
+          </a:p>
+          <a:p>
+            <a:pPr>
+              <a:spcAft>
+                <a:spcPts val="600"/>
+              </a:spcAft>
+            </a:pPr>
+            <a:r>
+              <a:rPr sz="1800" b="0">
+                <a:solidFill>
+                  <a:srgbClr val="1F1F1F"/>
+                </a:solidFill>
+                <a:latin typeface="Malgun Gothic"/>
+              </a:rPr>
+              <a:t>•  5. 배포 실험 (장기학습 · 양자화 · Distillation)</a:t>
+            </a:r>
+          </a:p>
+          <a:p>
+            <a:pPr>
+              <a:spcAft>
+                <a:spcPts val="600"/>
+              </a:spcAft>
+            </a:pPr>
+            <a:r>
+              <a:rPr sz="1800" b="0">
+                <a:solidFill>
+                  <a:srgbClr val="1F1F1F"/>
+                </a:solidFill>
+                <a:latin typeface="Malgun Gothic"/>
+              </a:rPr>
+              <a:t>•  6. 분석 노트북 &amp; 핵심 인사이트</a:t>
+            </a:r>
+          </a:p>
+          <a:p>
+            <a:pPr>
+              <a:spcAft>
+                <a:spcPts val="600"/>
+              </a:spcAft>
+            </a:pPr>
+            <a:r>
+              <a:rPr sz="1800" b="0">
+                <a:solidFill>
+                  <a:srgbClr val="1F1F1F"/>
+                </a:solidFill>
+                <a:latin typeface="Malgun Gothic"/>
+              </a:rPr>
+              <a:t>•  7. 한계 &amp; 향후 계획</a:t>
+            </a:r>
+          </a:p>
+        </p:txBody>
+      </p:sp>
+    </p:spTree>
+  </p:cSld>
+  <p:clrMapOvr>
+    <a:masterClrMapping/>
+  </p:clrMapOvr>
+</p:sld>
+</file>
+
+<file path=ppt/slides/slide20.xml><?xml version="1.0" encoding="utf-8"?>
 <p:sld xmlns:a="http://schemas.openxmlformats.org/drawingml/2006/main" xmlns:p="http://schemas.openxmlformats.org/presentationml/2006/main" xmlns:r="http://schemas.openxmlformats.org/officeDocument/2006/relationships">
   <p:cSld>
     <p:spTree>
@@ -7464,7 +8886,7 @@
 </p:sld>
 </file>
 
-<file path=ppt/slides/slide17.xml><?xml version="1.0" encoding="utf-8"?>
+<file path=ppt/slides/slide21.xml><?xml version="1.0" encoding="utf-8"?>
 <p:sld xmlns:a="http://schemas.openxmlformats.org/drawingml/2006/main" xmlns:p="http://schemas.openxmlformats.org/presentationml/2006/main" xmlns:r="http://schemas.openxmlformats.org/officeDocument/2006/relationships">
   <p:cSld>
     <p:spTree>
@@ -7570,7 +8992,7 @@
 </p:sld>
 </file>
 
-<file path=ppt/slides/slide18.xml><?xml version="1.0" encoding="utf-8"?>
+<file path=ppt/slides/slide22.xml><?xml version="1.0" encoding="utf-8"?>
 <p:sld xmlns:a="http://schemas.openxmlformats.org/drawingml/2006/main" xmlns:p="http://schemas.openxmlformats.org/presentationml/2006/main" xmlns:r="http://schemas.openxmlformats.org/officeDocument/2006/relationships">
   <p:cSld>
     <p:spTree>
@@ -7800,7 +9222,7 @@
 </p:sld>
 </file>
 
-<file path=ppt/slides/slide19.xml><?xml version="1.0" encoding="utf-8"?>
+<file path=ppt/slides/slide23.xml><?xml version="1.0" encoding="utf-8"?>
 <p:sld xmlns:a="http://schemas.openxmlformats.org/drawingml/2006/main" xmlns:p="http://schemas.openxmlformats.org/presentationml/2006/main" xmlns:r="http://schemas.openxmlformats.org/officeDocument/2006/relationships">
   <p:cSld>
     <p:spTree>
@@ -8046,269 +9468,7 @@
 </p:sld>
 </file>
 
-<file path=ppt/slides/slide2.xml><?xml version="1.0" encoding="utf-8"?>
-<p:sld xmlns:a="http://schemas.openxmlformats.org/drawingml/2006/main" xmlns:p="http://schemas.openxmlformats.org/presentationml/2006/main" xmlns:r="http://schemas.openxmlformats.org/officeDocument/2006/relationships">
-  <p:cSld>
-    <p:spTree>
-      <p:nvGrpSpPr>
-        <p:cNvPr id="1" name=""/>
-        <p:cNvGrpSpPr/>
-        <p:nvPr/>
-      </p:nvGrpSpPr>
-      <p:grpSpPr/>
-      <p:sp>
-        <p:nvSpPr>
-          <p:cNvPr id="2" name="TextBox 1"/>
-          <p:cNvSpPr txBox="1"/>
-          <p:nvPr/>
-        </p:nvSpPr>
-        <p:spPr>
-          <a:xfrm>
-            <a:off x="457200" y="274320"/>
-            <a:ext cx="11277295" cy="822960"/>
-          </a:xfrm>
-          <a:prstGeom prst="rect">
-            <a:avLst/>
-          </a:prstGeom>
-          <a:noFill/>
-        </p:spPr>
-        <p:txBody>
-          <a:bodyPr wrap="square">
-            <a:spAutoFit/>
-          </a:bodyPr>
-          <a:lstStyle/>
-          <a:p>
-            <a:r>
-              <a:rPr sz="2800" b="1">
-                <a:solidFill>
-                  <a:srgbClr val="165B33"/>
-                </a:solidFill>
-                <a:latin typeface="Malgun Gothic"/>
-              </a:rPr>
-              <a:t>목차</a:t>
-            </a:r>
-          </a:p>
-        </p:txBody>
-      </p:sp>
-      <p:sp>
-        <p:nvSpPr>
-          <p:cNvPr id="3" name="Rectangle 2"/>
-          <p:cNvSpPr/>
-          <p:nvPr/>
-        </p:nvSpPr>
-        <p:spPr>
-          <a:xfrm>
-            <a:off x="457200" y="1051560"/>
-            <a:ext cx="1371600" cy="38100"/>
-          </a:xfrm>
-          <a:prstGeom prst="rect">
-            <a:avLst/>
-          </a:prstGeom>
-          <a:solidFill>
-            <a:srgbClr val="E87200"/>
-          </a:solidFill>
-          <a:ln>
-            <a:noFill/>
-          </a:ln>
-        </p:spPr>
-        <p:style>
-          <a:lnRef idx="1">
-            <a:schemeClr val="accent1"/>
-          </a:lnRef>
-          <a:fillRef idx="3">
-            <a:schemeClr val="accent1"/>
-          </a:fillRef>
-          <a:effectRef idx="2">
-            <a:schemeClr val="accent1"/>
-          </a:effectRef>
-          <a:fontRef idx="minor">
-            <a:schemeClr val="lt1"/>
-          </a:fontRef>
-        </p:style>
-        <p:txBody>
-          <a:bodyPr rtlCol="0" anchor="ctr"/>
-          <a:lstStyle/>
-          <a:p>
-            <a:pPr algn="ctr"/>
-          </a:p>
-        </p:txBody>
-      </p:sp>
-      <p:sp>
-        <p:nvSpPr>
-          <p:cNvPr id="4" name="TextBox 3"/>
-          <p:cNvSpPr txBox="1"/>
-          <p:nvPr/>
-        </p:nvSpPr>
-        <p:spPr>
-          <a:xfrm>
-            <a:off x="457200" y="1280160"/>
-            <a:ext cx="11277295" cy="5303520"/>
-          </a:xfrm>
-          <a:prstGeom prst="rect">
-            <a:avLst/>
-          </a:prstGeom>
-          <a:noFill/>
-        </p:spPr>
-        <p:txBody>
-          <a:bodyPr wrap="square">
-            <a:spAutoFit/>
-          </a:bodyPr>
-          <a:lstStyle/>
-          <a:p>
-            <a:pPr>
-              <a:spcAft>
-                <a:spcPts val="600"/>
-              </a:spcAft>
-            </a:pPr>
-            <a:r>
-              <a:rPr sz="1800" b="0">
-                <a:solidFill>
-                  <a:srgbClr val="1F1F1F"/>
-                </a:solidFill>
-                <a:latin typeface="Malgun Gothic"/>
-              </a:rPr>
-              <a:t>•  1. 프로젝트 개요 (목적 · 데이터)</a:t>
-            </a:r>
-          </a:p>
-          <a:p>
-            <a:pPr>
-              <a:spcAft>
-                <a:spcPts val="600"/>
-              </a:spcAft>
-            </a:pPr>
-            <a:r>
-              <a:rPr sz="1800" b="0">
-                <a:solidFill>
-                  <a:srgbClr val="1F1F1F"/>
-                </a:solidFill>
-                <a:latin typeface="Malgun Gothic"/>
-              </a:rPr>
-              <a:t>•  2. 아키텍처 &amp; 파이프라인 설계</a:t>
-            </a:r>
-          </a:p>
-          <a:p>
-            <a:pPr>
-              <a:spcAft>
-                <a:spcPts val="600"/>
-              </a:spcAft>
-            </a:pPr>
-            <a:r>
-              <a:rPr sz="1800" b="0">
-                <a:solidFill>
-                  <a:srgbClr val="1F1F1F"/>
-                </a:solidFill>
-                <a:latin typeface="Malgun Gothic"/>
-              </a:rPr>
-              <a:t>•  3. 3가지 CV 태스크 구현</a:t>
-            </a:r>
-          </a:p>
-          <a:p>
-            <a:pPr lvl="1">
-              <a:spcAft>
-                <a:spcPts val="600"/>
-              </a:spcAft>
-            </a:pPr>
-            <a:r>
-              <a:rPr sz="1500" b="0">
-                <a:solidFill>
-                  <a:srgbClr val="555555"/>
-                </a:solidFill>
-                <a:latin typeface="Malgun Gothic"/>
-              </a:rPr>
-              <a:t>    –  P1 Classification / P2 Detection / P3 Segmentation</a:t>
-            </a:r>
-          </a:p>
-          <a:p>
-            <a:pPr>
-              <a:spcAft>
-                <a:spcPts val="600"/>
-              </a:spcAft>
-            </a:pPr>
-            <a:r>
-              <a:rPr sz="1800" b="0">
-                <a:solidFill>
-                  <a:srgbClr val="1F1F1F"/>
-                </a:solidFill>
-                <a:latin typeface="Malgun Gothic"/>
-              </a:rPr>
-              <a:t>•  4. 비교 실험 3종</a:t>
-            </a:r>
-          </a:p>
-          <a:p>
-            <a:pPr lvl="1">
-              <a:spcAft>
-                <a:spcPts val="600"/>
-              </a:spcAft>
-            </a:pPr>
-            <a:r>
-              <a:rPr sz="1500" b="0">
-                <a:solidFill>
-                  <a:srgbClr val="555555"/>
-                </a:solidFill>
-                <a:latin typeface="Malgun Gothic"/>
-              </a:rPr>
-              <a:t>    –  P1b 백본 / P2b YOLO / P3b Seg 아키텍처</a:t>
-            </a:r>
-          </a:p>
-          <a:p>
-            <a:pPr>
-              <a:spcAft>
-                <a:spcPts val="600"/>
-              </a:spcAft>
-            </a:pPr>
-            <a:r>
-              <a:rPr sz="1800" b="0">
-                <a:solidFill>
-                  <a:srgbClr val="1F1F1F"/>
-                </a:solidFill>
-                <a:latin typeface="Malgun Gothic"/>
-              </a:rPr>
-              <a:t>•  5. 배포 실험 (장기학습 · 양자화 · Distillation)</a:t>
-            </a:r>
-          </a:p>
-          <a:p>
-            <a:pPr>
-              <a:spcAft>
-                <a:spcPts val="600"/>
-              </a:spcAft>
-            </a:pPr>
-            <a:r>
-              <a:rPr sz="1800" b="0">
-                <a:solidFill>
-                  <a:srgbClr val="1F1F1F"/>
-                </a:solidFill>
-                <a:latin typeface="Malgun Gothic"/>
-              </a:rPr>
-              <a:t>•  6. 분석 노트북 &amp; 핵심 인사이트</a:t>
-            </a:r>
-          </a:p>
-          <a:p>
-            <a:pPr>
-              <a:spcAft>
-                <a:spcPts val="600"/>
-              </a:spcAft>
-            </a:pPr>
-            <a:r>
-              <a:rPr sz="1800" b="0">
-                <a:solidFill>
-                  <a:srgbClr val="1F1F1F"/>
-                </a:solidFill>
-                <a:latin typeface="Malgun Gothic"/>
-              </a:rPr>
-              <a:t>•  7. 한계 &amp; 향후 계획</a:t>
-            </a:r>
-          </a:p>
-        </p:txBody>
-      </p:sp>
-    </p:spTree>
-  </p:cSld>
-  <p:clrMapOvr>
-    <a:masterClrMapping/>
-  </p:clrMapOvr>
-</p:sld>
-</file>
-
-<file path=ppt/slides/slide20.xml><?xml version="1.0" encoding="utf-8"?>
+<file path=ppt/slides/slide24.xml><?xml version="1.0" encoding="utf-8"?>
 <p:sld xmlns:a="http://schemas.openxmlformats.org/drawingml/2006/main" xmlns:p="http://schemas.openxmlformats.org/presentationml/2006/main" xmlns:r="http://schemas.openxmlformats.org/officeDocument/2006/relationships">
   <p:cSld>
     <p:spTree>
@@ -8853,7 +10013,7 @@
 </p:sld>
 </file>
 
-<file path=ppt/slides/slide21.xml><?xml version="1.0" encoding="utf-8"?>
+<file path=ppt/slides/slide25.xml><?xml version="1.0" encoding="utf-8"?>
 <p:sld xmlns:a="http://schemas.openxmlformats.org/drawingml/2006/main" xmlns:p="http://schemas.openxmlformats.org/presentationml/2006/main" xmlns:r="http://schemas.openxmlformats.org/officeDocument/2006/relationships">
   <p:cSld>
     <p:spTree>
@@ -9147,7 +10307,7 @@
 </p:sld>
 </file>
 
-<file path=ppt/slides/slide22.xml><?xml version="1.0" encoding="utf-8"?>
+<file path=ppt/slides/slide26.xml><?xml version="1.0" encoding="utf-8"?>
 <p:sld xmlns:a="http://schemas.openxmlformats.org/drawingml/2006/main" xmlns:p="http://schemas.openxmlformats.org/presentationml/2006/main" xmlns:r="http://schemas.openxmlformats.org/officeDocument/2006/relationships">
   <p:cSld>
     <p:spTree>
@@ -9253,7 +10413,315 @@
 </p:sld>
 </file>
 
-<file path=ppt/slides/slide23.xml><?xml version="1.0" encoding="utf-8"?>
+<file path=ppt/slides/slide27.xml><?xml version="1.0" encoding="utf-8"?>
+<p:sld xmlns:a="http://schemas.openxmlformats.org/drawingml/2006/main" xmlns:p="http://schemas.openxmlformats.org/presentationml/2006/main" xmlns:r="http://schemas.openxmlformats.org/officeDocument/2006/relationships">
+  <p:cSld>
+    <p:spTree>
+      <p:nvGrpSpPr>
+        <p:cNvPr id="1" name=""/>
+        <p:cNvGrpSpPr/>
+        <p:nvPr/>
+      </p:nvGrpSpPr>
+      <p:grpSpPr/>
+      <p:sp>
+        <p:nvSpPr>
+          <p:cNvPr id="2" name="TextBox 1"/>
+          <p:cNvSpPr txBox="1"/>
+          <p:nvPr/>
+        </p:nvSpPr>
+        <p:spPr>
+          <a:xfrm>
+            <a:off x="457200" y="274320"/>
+            <a:ext cx="11277295" cy="822960"/>
+          </a:xfrm>
+          <a:prstGeom prst="rect">
+            <a:avLst/>
+          </a:prstGeom>
+          <a:noFill/>
+        </p:spPr>
+        <p:txBody>
+          <a:bodyPr wrap="square">
+            <a:spAutoFit/>
+          </a:bodyPr>
+          <a:lstStyle/>
+          <a:p>
+            <a:r>
+              <a:rPr sz="2600" b="1">
+                <a:solidFill>
+                  <a:srgbClr val="165B33"/>
+                </a:solidFill>
+                <a:latin typeface="Malgun Gothic"/>
+              </a:rPr>
+              <a:t>결과 이미지 — Grad-CAM (정상 샘플)</a:t>
+            </a:r>
+          </a:p>
+        </p:txBody>
+      </p:sp>
+      <p:sp>
+        <p:nvSpPr>
+          <p:cNvPr id="3" name="Rectangle 2"/>
+          <p:cNvSpPr/>
+          <p:nvPr/>
+        </p:nvSpPr>
+        <p:spPr>
+          <a:xfrm>
+            <a:off x="457200" y="1005840"/>
+            <a:ext cx="1371600" cy="38100"/>
+          </a:xfrm>
+          <a:prstGeom prst="rect">
+            <a:avLst/>
+          </a:prstGeom>
+          <a:solidFill>
+            <a:srgbClr val="E87200"/>
+          </a:solidFill>
+          <a:ln>
+            <a:noFill/>
+          </a:ln>
+        </p:spPr>
+        <p:style>
+          <a:lnRef idx="1">
+            <a:schemeClr val="accent1"/>
+          </a:lnRef>
+          <a:fillRef idx="3">
+            <a:schemeClr val="accent1"/>
+          </a:fillRef>
+          <a:effectRef idx="2">
+            <a:schemeClr val="accent1"/>
+          </a:effectRef>
+          <a:fontRef idx="minor">
+            <a:schemeClr val="lt1"/>
+          </a:fontRef>
+        </p:style>
+        <p:txBody>
+          <a:bodyPr rtlCol="0" anchor="ctr"/>
+          <a:lstStyle/>
+          <a:p>
+            <a:pPr algn="ctr"/>
+          </a:p>
+        </p:txBody>
+      </p:sp>
+      <p:pic>
+        <p:nvPicPr>
+          <p:cNvPr id="4" name="Picture 3" descr="nb07_gradcam_01.png"/>
+          <p:cNvPicPr>
+            <a:picLocks noChangeAspect="1"/>
+          </p:cNvPicPr>
+          <p:nvPr/>
+        </p:nvPicPr>
+        <p:blipFill>
+          <a:blip r:embed="rId2"/>
+          <a:stretch>
+            <a:fillRect/>
+          </a:stretch>
+        </p:blipFill>
+        <p:spPr>
+          <a:xfrm>
+            <a:off x="4937269" y="1280160"/>
+            <a:ext cx="2317157" cy="5029200"/>
+          </a:xfrm>
+          <a:prstGeom prst="rect">
+            <a:avLst/>
+          </a:prstGeom>
+        </p:spPr>
+      </p:pic>
+      <p:sp>
+        <p:nvSpPr>
+          <p:cNvPr id="5" name="TextBox 4"/>
+          <p:cNvSpPr txBox="1"/>
+          <p:nvPr/>
+        </p:nvSpPr>
+        <p:spPr>
+          <a:xfrm>
+            <a:off x="457200" y="6400800"/>
+            <a:ext cx="11277295" cy="274320"/>
+          </a:xfrm>
+          <a:prstGeom prst="rect">
+            <a:avLst/>
+          </a:prstGeom>
+          <a:noFill/>
+        </p:spPr>
+        <p:txBody>
+          <a:bodyPr wrap="square">
+            <a:spAutoFit/>
+          </a:bodyPr>
+          <a:lstStyle/>
+          <a:p>
+            <a:pPr algn="ctr"/>
+            <a:r>
+              <a:rPr sz="1200" b="0" i="1">
+                <a:solidFill>
+                  <a:srgbClr val="555555"/>
+                </a:solidFill>
+                <a:latin typeface="Malgun Gothic"/>
+              </a:rPr>
+              <a:t>4장의 정상 감귤 샘플에 Grad-CAM overlay — 모델이 어디를 보는가</a:t>
+            </a:r>
+          </a:p>
+        </p:txBody>
+      </p:sp>
+    </p:spTree>
+  </p:cSld>
+  <p:clrMapOvr>
+    <a:masterClrMapping/>
+  </p:clrMapOvr>
+</p:sld>
+</file>
+
+<file path=ppt/slides/slide28.xml><?xml version="1.0" encoding="utf-8"?>
+<p:sld xmlns:a="http://schemas.openxmlformats.org/drawingml/2006/main" xmlns:p="http://schemas.openxmlformats.org/presentationml/2006/main" xmlns:r="http://schemas.openxmlformats.org/officeDocument/2006/relationships">
+  <p:cSld>
+    <p:spTree>
+      <p:nvGrpSpPr>
+        <p:cNvPr id="1" name=""/>
+        <p:cNvGrpSpPr/>
+        <p:nvPr/>
+      </p:nvGrpSpPr>
+      <p:grpSpPr/>
+      <p:sp>
+        <p:nvSpPr>
+          <p:cNvPr id="2" name="TextBox 1"/>
+          <p:cNvSpPr txBox="1"/>
+          <p:nvPr/>
+        </p:nvSpPr>
+        <p:spPr>
+          <a:xfrm>
+            <a:off x="457200" y="274320"/>
+            <a:ext cx="11277295" cy="822960"/>
+          </a:xfrm>
+          <a:prstGeom prst="rect">
+            <a:avLst/>
+          </a:prstGeom>
+          <a:noFill/>
+        </p:spPr>
+        <p:txBody>
+          <a:bodyPr wrap="square">
+            <a:spAutoFit/>
+          </a:bodyPr>
+          <a:lstStyle/>
+          <a:p>
+            <a:r>
+              <a:rPr sz="2600" b="1">
+                <a:solidFill>
+                  <a:srgbClr val="165B33"/>
+                </a:solidFill>
+                <a:latin typeface="Malgun Gothic"/>
+              </a:rPr>
+              <a:t>결과 이미지 — Grad-CAM (궤양병 샘플)</a:t>
+            </a:r>
+          </a:p>
+        </p:txBody>
+      </p:sp>
+      <p:sp>
+        <p:nvSpPr>
+          <p:cNvPr id="3" name="Rectangle 2"/>
+          <p:cNvSpPr/>
+          <p:nvPr/>
+        </p:nvSpPr>
+        <p:spPr>
+          <a:xfrm>
+            <a:off x="457200" y="1005840"/>
+            <a:ext cx="1371600" cy="38100"/>
+          </a:xfrm>
+          <a:prstGeom prst="rect">
+            <a:avLst/>
+          </a:prstGeom>
+          <a:solidFill>
+            <a:srgbClr val="E87200"/>
+          </a:solidFill>
+          <a:ln>
+            <a:noFill/>
+          </a:ln>
+        </p:spPr>
+        <p:style>
+          <a:lnRef idx="1">
+            <a:schemeClr val="accent1"/>
+          </a:lnRef>
+          <a:fillRef idx="3">
+            <a:schemeClr val="accent1"/>
+          </a:fillRef>
+          <a:effectRef idx="2">
+            <a:schemeClr val="accent1"/>
+          </a:effectRef>
+          <a:fontRef idx="minor">
+            <a:schemeClr val="lt1"/>
+          </a:fontRef>
+        </p:style>
+        <p:txBody>
+          <a:bodyPr rtlCol="0" anchor="ctr"/>
+          <a:lstStyle/>
+          <a:p>
+            <a:pPr algn="ctr"/>
+          </a:p>
+        </p:txBody>
+      </p:sp>
+      <p:pic>
+        <p:nvPicPr>
+          <p:cNvPr id="4" name="Picture 3" descr="nb07_gradcam_02.png"/>
+          <p:cNvPicPr>
+            <a:picLocks noChangeAspect="1"/>
+          </p:cNvPicPr>
+          <p:nvPr/>
+        </p:nvPicPr>
+        <p:blipFill>
+          <a:blip r:embed="rId2"/>
+          <a:stretch>
+            <a:fillRect/>
+          </a:stretch>
+        </p:blipFill>
+        <p:spPr>
+          <a:xfrm>
+            <a:off x="4937269" y="1280160"/>
+            <a:ext cx="2317157" cy="5029200"/>
+          </a:xfrm>
+          <a:prstGeom prst="rect">
+            <a:avLst/>
+          </a:prstGeom>
+        </p:spPr>
+      </p:pic>
+      <p:sp>
+        <p:nvSpPr>
+          <p:cNvPr id="5" name="TextBox 4"/>
+          <p:cNvSpPr txBox="1"/>
+          <p:nvPr/>
+        </p:nvSpPr>
+        <p:spPr>
+          <a:xfrm>
+            <a:off x="457200" y="6400800"/>
+            <a:ext cx="11277295" cy="274320"/>
+          </a:xfrm>
+          <a:prstGeom prst="rect">
+            <a:avLst/>
+          </a:prstGeom>
+          <a:noFill/>
+        </p:spPr>
+        <p:txBody>
+          <a:bodyPr wrap="square">
+            <a:spAutoFit/>
+          </a:bodyPr>
+          <a:lstStyle/>
+          <a:p>
+            <a:pPr algn="ctr"/>
+            <a:r>
+              <a:rPr sz="1200" b="0" i="1">
+                <a:solidFill>
+                  <a:srgbClr val="555555"/>
+                </a:solidFill>
+                <a:latin typeface="Malgun Gothic"/>
+              </a:rPr>
+              <a:t>궤양병 감귤 샘플 Grad-CAM — 병변 추정 영역에 activation 집중</a:t>
+            </a:r>
+          </a:p>
+        </p:txBody>
+      </p:sp>
+    </p:spTree>
+  </p:cSld>
+  <p:clrMapOvr>
+    <a:masterClrMapping/>
+  </p:clrMapOvr>
+</p:sld>
+</file>
+
+<file path=ppt/slides/slide29.xml><?xml version="1.0" encoding="utf-8"?>
 <p:sld xmlns:a="http://schemas.openxmlformats.org/drawingml/2006/main" xmlns:p="http://schemas.openxmlformats.org/presentationml/2006/main" xmlns:r="http://schemas.openxmlformats.org/officeDocument/2006/relationships">
   <p:cSld>
     <p:spTree>
@@ -9499,7 +10967,113 @@
 </p:sld>
 </file>
 
-<file path=ppt/slides/slide24.xml><?xml version="1.0" encoding="utf-8"?>
+<file path=ppt/slides/slide3.xml><?xml version="1.0" encoding="utf-8"?>
+<p:sld xmlns:a="http://schemas.openxmlformats.org/drawingml/2006/main" xmlns:p="http://schemas.openxmlformats.org/presentationml/2006/main" xmlns:r="http://schemas.openxmlformats.org/officeDocument/2006/relationships">
+  <p:cSld>
+    <p:spTree>
+      <p:nvGrpSpPr>
+        <p:cNvPr id="1" name=""/>
+        <p:cNvGrpSpPr/>
+        <p:nvPr/>
+      </p:nvGrpSpPr>
+      <p:grpSpPr/>
+      <p:sp>
+        <p:nvSpPr>
+          <p:cNvPr id="2" name="Rectangle 1"/>
+          <p:cNvSpPr/>
+          <p:nvPr/>
+        </p:nvSpPr>
+        <p:spPr>
+          <a:xfrm>
+            <a:off x="0" y="0"/>
+            <a:ext cx="12191695" cy="6858000"/>
+          </a:xfrm>
+          <a:prstGeom prst="rect">
+            <a:avLst/>
+          </a:prstGeom>
+          <a:solidFill>
+            <a:srgbClr val="165B33"/>
+          </a:solidFill>
+          <a:ln>
+            <a:noFill/>
+          </a:ln>
+        </p:spPr>
+        <p:style>
+          <a:lnRef idx="1">
+            <a:schemeClr val="accent1"/>
+          </a:lnRef>
+          <a:fillRef idx="3">
+            <a:schemeClr val="accent1"/>
+          </a:fillRef>
+          <a:effectRef idx="2">
+            <a:schemeClr val="accent1"/>
+          </a:effectRef>
+          <a:fontRef idx="minor">
+            <a:schemeClr val="lt1"/>
+          </a:fontRef>
+        </p:style>
+        <p:txBody>
+          <a:bodyPr rtlCol="0" anchor="ctr"/>
+          <a:lstStyle/>
+          <a:p>
+            <a:pPr algn="ctr"/>
+          </a:p>
+        </p:txBody>
+      </p:sp>
+      <p:sp>
+        <p:nvSpPr>
+          <p:cNvPr id="3" name="TextBox 2"/>
+          <p:cNvSpPr txBox="1"/>
+          <p:nvPr/>
+        </p:nvSpPr>
+        <p:spPr>
+          <a:xfrm>
+            <a:off x="640080" y="2560320"/>
+            <a:ext cx="10911535" cy="2286000"/>
+          </a:xfrm>
+          <a:prstGeom prst="rect">
+            <a:avLst/>
+          </a:prstGeom>
+          <a:noFill/>
+        </p:spPr>
+        <p:txBody>
+          <a:bodyPr wrap="square">
+            <a:spAutoFit/>
+          </a:bodyPr>
+          <a:lstStyle/>
+          <a:p>
+            <a:r>
+              <a:rPr sz="4000" b="1">
+                <a:solidFill>
+                  <a:srgbClr val="FFFFFF"/>
+                </a:solidFill>
+                <a:latin typeface="Malgun Gothic"/>
+              </a:rPr>
+              <a:t>1. 프로젝트 개요</a:t>
+            </a:r>
+          </a:p>
+          <a:p>
+            <a:r>
+              <a:rPr sz="1800" b="0">
+                <a:solidFill>
+                  <a:srgbClr val="FFFFFF"/>
+                </a:solidFill>
+                <a:latin typeface="Malgun Gothic"/>
+              </a:rPr>
+              <a:t>목적과 데이터셋</a:t>
+            </a:r>
+          </a:p>
+        </p:txBody>
+      </p:sp>
+    </p:spTree>
+  </p:cSld>
+  <p:clrMapOvr>
+    <a:masterClrMapping/>
+  </p:clrMapOvr>
+</p:sld>
+</file>
+
+<file path=ppt/slides/slide30.xml><?xml version="1.0" encoding="utf-8"?>
 <p:sld xmlns:a="http://schemas.openxmlformats.org/drawingml/2006/main" xmlns:p="http://schemas.openxmlformats.org/presentationml/2006/main" xmlns:r="http://schemas.openxmlformats.org/officeDocument/2006/relationships">
   <p:cSld>
     <p:spTree>
@@ -9761,7 +11335,7 @@
 </p:sld>
 </file>
 
-<file path=ppt/slides/slide25.xml><?xml version="1.0" encoding="utf-8"?>
+<file path=ppt/slides/slide31.xml><?xml version="1.0" encoding="utf-8"?>
 <p:sld xmlns:a="http://schemas.openxmlformats.org/drawingml/2006/main" xmlns:p="http://schemas.openxmlformats.org/presentationml/2006/main" xmlns:r="http://schemas.openxmlformats.org/officeDocument/2006/relationships">
   <p:cSld>
     <p:spTree>
@@ -10023,7 +11597,7 @@
 </p:sld>
 </file>
 
-<file path=ppt/slides/slide26.xml><?xml version="1.0" encoding="utf-8"?>
+<file path=ppt/slides/slide32.xml><?xml version="1.0" encoding="utf-8"?>
 <p:sld xmlns:a="http://schemas.openxmlformats.org/drawingml/2006/main" xmlns:p="http://schemas.openxmlformats.org/presentationml/2006/main" xmlns:r="http://schemas.openxmlformats.org/officeDocument/2006/relationships">
   <p:cSld>
     <p:spTree>
@@ -10333,7 +11907,7 @@
 </p:sld>
 </file>
 
-<file path=ppt/slides/slide27.xml><?xml version="1.0" encoding="utf-8"?>
+<file path=ppt/slides/slide33.xml><?xml version="1.0" encoding="utf-8"?>
 <p:sld xmlns:a="http://schemas.openxmlformats.org/drawingml/2006/main" xmlns:p="http://schemas.openxmlformats.org/presentationml/2006/main" xmlns:r="http://schemas.openxmlformats.org/officeDocument/2006/relationships">
   <p:cSld>
     <p:spTree>
@@ -10439,7 +12013,7 @@
 </p:sld>
 </file>
 
-<file path=ppt/slides/slide28.xml><?xml version="1.0" encoding="utf-8"?>
+<file path=ppt/slides/slide34.xml><?xml version="1.0" encoding="utf-8"?>
 <p:sld xmlns:a="http://schemas.openxmlformats.org/drawingml/2006/main" xmlns:p="http://schemas.openxmlformats.org/presentationml/2006/main" xmlns:r="http://schemas.openxmlformats.org/officeDocument/2006/relationships">
   <p:cSld>
     <p:spTree>
@@ -10733,7 +12307,7 @@
 </p:sld>
 </file>
 
-<file path=ppt/slides/slide29.xml><?xml version="1.0" encoding="utf-8"?>
+<file path=ppt/slides/slide35.xml><?xml version="1.0" encoding="utf-8"?>
 <p:sld xmlns:a="http://schemas.openxmlformats.org/drawingml/2006/main" xmlns:p="http://schemas.openxmlformats.org/presentationml/2006/main" xmlns:r="http://schemas.openxmlformats.org/officeDocument/2006/relationships">
   <p:cSld>
     <p:spTree>
@@ -11011,7 +12585,7 @@
 </p:sld>
 </file>
 
-<file path=ppt/slides/slide3.xml><?xml version="1.0" encoding="utf-8"?>
+<file path=ppt/slides/slide36.xml><?xml version="1.0" encoding="utf-8"?>
 <p:sld xmlns:a="http://schemas.openxmlformats.org/drawingml/2006/main" xmlns:p="http://schemas.openxmlformats.org/presentationml/2006/main" xmlns:r="http://schemas.openxmlformats.org/officeDocument/2006/relationships">
   <p:cSld>
     <p:spTree>
@@ -11093,7 +12667,7 @@
                 </a:solidFill>
                 <a:latin typeface="Malgun Gothic"/>
               </a:rPr>
-              <a:t>1. 프로젝트 개요</a:t>
+              <a:t>요약</a:t>
             </a:r>
           </a:p>
           <a:p>
@@ -11104,7 +12678,7 @@
                 </a:solidFill>
                 <a:latin typeface="Malgun Gothic"/>
               </a:rPr>
-              <a:t>목적과 데이터셋</a:t>
+              <a:t>개발 성과 · 학습 · 공개</a:t>
             </a:r>
           </a:p>
         </p:txBody>
@@ -11117,113 +12691,7 @@
 </p:sld>
 </file>
 
-<file path=ppt/slides/slide30.xml><?xml version="1.0" encoding="utf-8"?>
-<p:sld xmlns:a="http://schemas.openxmlformats.org/drawingml/2006/main" xmlns:p="http://schemas.openxmlformats.org/presentationml/2006/main" xmlns:r="http://schemas.openxmlformats.org/officeDocument/2006/relationships">
-  <p:cSld>
-    <p:spTree>
-      <p:nvGrpSpPr>
-        <p:cNvPr id="1" name=""/>
-        <p:cNvGrpSpPr/>
-        <p:nvPr/>
-      </p:nvGrpSpPr>
-      <p:grpSpPr/>
-      <p:sp>
-        <p:nvSpPr>
-          <p:cNvPr id="2" name="Rectangle 1"/>
-          <p:cNvSpPr/>
-          <p:nvPr/>
-        </p:nvSpPr>
-        <p:spPr>
-          <a:xfrm>
-            <a:off x="0" y="0"/>
-            <a:ext cx="12191695" cy="6858000"/>
-          </a:xfrm>
-          <a:prstGeom prst="rect">
-            <a:avLst/>
-          </a:prstGeom>
-          <a:solidFill>
-            <a:srgbClr val="165B33"/>
-          </a:solidFill>
-          <a:ln>
-            <a:noFill/>
-          </a:ln>
-        </p:spPr>
-        <p:style>
-          <a:lnRef idx="1">
-            <a:schemeClr val="accent1"/>
-          </a:lnRef>
-          <a:fillRef idx="3">
-            <a:schemeClr val="accent1"/>
-          </a:fillRef>
-          <a:effectRef idx="2">
-            <a:schemeClr val="accent1"/>
-          </a:effectRef>
-          <a:fontRef idx="minor">
-            <a:schemeClr val="lt1"/>
-          </a:fontRef>
-        </p:style>
-        <p:txBody>
-          <a:bodyPr rtlCol="0" anchor="ctr"/>
-          <a:lstStyle/>
-          <a:p>
-            <a:pPr algn="ctr"/>
-          </a:p>
-        </p:txBody>
-      </p:sp>
-      <p:sp>
-        <p:nvSpPr>
-          <p:cNvPr id="3" name="TextBox 2"/>
-          <p:cNvSpPr txBox="1"/>
-          <p:nvPr/>
-        </p:nvSpPr>
-        <p:spPr>
-          <a:xfrm>
-            <a:off x="640080" y="2560320"/>
-            <a:ext cx="10911535" cy="2286000"/>
-          </a:xfrm>
-          <a:prstGeom prst="rect">
-            <a:avLst/>
-          </a:prstGeom>
-          <a:noFill/>
-        </p:spPr>
-        <p:txBody>
-          <a:bodyPr wrap="square">
-            <a:spAutoFit/>
-          </a:bodyPr>
-          <a:lstStyle/>
-          <a:p>
-            <a:r>
-              <a:rPr sz="4000" b="1">
-                <a:solidFill>
-                  <a:srgbClr val="FFFFFF"/>
-                </a:solidFill>
-                <a:latin typeface="Malgun Gothic"/>
-              </a:rPr>
-              <a:t>요약</a:t>
-            </a:r>
-          </a:p>
-          <a:p>
-            <a:r>
-              <a:rPr sz="1800" b="0">
-                <a:solidFill>
-                  <a:srgbClr val="FFFFFF"/>
-                </a:solidFill>
-                <a:latin typeface="Malgun Gothic"/>
-              </a:rPr>
-              <a:t>개발 성과 · 학습 · 공개</a:t>
-            </a:r>
-          </a:p>
-        </p:txBody>
-      </p:sp>
-    </p:spTree>
-  </p:cSld>
-  <p:clrMapOvr>
-    <a:masterClrMapping/>
-  </p:clrMapOvr>
-</p:sld>
-</file>
-
-<file path=ppt/slides/slide31.xml><?xml version="1.0" encoding="utf-8"?>
+<file path=ppt/slides/slide37.xml><?xml version="1.0" encoding="utf-8"?>
 <p:sld xmlns:a="http://schemas.openxmlformats.org/drawingml/2006/main" xmlns:p="http://schemas.openxmlformats.org/presentationml/2006/main" xmlns:r="http://schemas.openxmlformats.org/officeDocument/2006/relationships">
   <p:cSld>
     <p:spTree>
@@ -11517,7 +12985,7 @@
 </p:sld>
 </file>
 
-<file path=ppt/slides/slide32.xml><?xml version="1.0" encoding="utf-8"?>
+<file path=ppt/slides/slide38.xml><?xml version="1.0" encoding="utf-8"?>
 <p:sld xmlns:a="http://schemas.openxmlformats.org/drawingml/2006/main" xmlns:p="http://schemas.openxmlformats.org/presentationml/2006/main" xmlns:r="http://schemas.openxmlformats.org/officeDocument/2006/relationships">
   <p:cSld>
     <p:spTree>
@@ -11811,7 +13279,7 @@
 </p:sld>
 </file>
 
-<file path=ppt/slides/slide33.xml><?xml version="1.0" encoding="utf-8"?>
+<file path=ppt/slides/slide39.xml><?xml version="1.0" encoding="utf-8"?>
 <p:sld xmlns:a="http://schemas.openxmlformats.org/drawingml/2006/main" xmlns:p="http://schemas.openxmlformats.org/presentationml/2006/main" xmlns:r="http://schemas.openxmlformats.org/officeDocument/2006/relationships">
   <p:cSld>
     <p:spTree>

</xml_diff>

<commit_message>
docs: clarify dataset is harvested-fruit inspection, not in-field early detection
Per feedback: AI Hub samples are post-harvest fruits (꼭지 잘린)
photographed against white backdrop for inspection. 'In-field 조기 감별'
framing was misleading.

Updates:
- README 문제 정의: reframed to 수확·선별 단계 품질 검수 + added
  explicit warning that current dataset doesn't cover on-tree samples
- PPT slide "프로젝트 목적": 3 bullets updated to reflect post-harvest QC
  (replace 조기 감별 → 수확·선별 단계 자동 품질 검수)
- PPT slide "데이터셋": clarify images are inspection-style, not field-shot

Co-Authored-By: Claude Opus 4.6 (1M context) <noreply@anthropic.com>
</commit_message>
<xml_diff>
--- a/docs/disease_01_presentation.pptx
+++ b/docs/disease_01_presentation.pptx
@@ -13533,7 +13533,23 @@
                 </a:solidFill>
                 <a:latin typeface="Malgun Gothic"/>
               </a:rPr>
-              <a:t>    –  감귤(온주밀감) 이미지로 정상 vs 궤양병(canker) 자동 감별</a:t>
+              <a:t>    –  수확된 감귤(온주밀감)의 정상 vs 궤양병(canker) 자동 검수</a:t>
+            </a:r>
+          </a:p>
+          <a:p>
+            <a:pPr lvl="1">
+              <a:spcAft>
+                <a:spcPts val="600"/>
+              </a:spcAft>
+            </a:pPr>
+            <a:r>
+              <a:rPr sz="1500" b="0">
+                <a:solidFill>
+                  <a:srgbClr val="555555"/>
+                </a:solidFill>
+                <a:latin typeface="Malgun Gothic"/>
+              </a:rPr>
+              <a:t>    –  데이터셋은 꼭지 잘린 수확 후 과일을 배경 분리된 환경에서 촬영</a:t>
             </a:r>
           </a:p>
           <a:p>
@@ -13565,7 +13581,7 @@
                 </a:solidFill>
                 <a:latin typeface="Malgun Gothic"/>
               </a:rPr>
-              <a:t>    –  궤양병은 수확량·상품성에 직접 타격</a:t>
+              <a:t>    –  궤양병은 감귤류 주요 질병 — 상품성·수출 검역에 직접 영향</a:t>
             </a:r>
           </a:p>
           <a:p>
@@ -13581,7 +13597,23 @@
                 </a:solidFill>
                 <a:latin typeface="Malgun Gothic"/>
               </a:rPr>
-              <a:t>    –  조기 감별로 선별·검역 비용 절감</a:t>
+              <a:t>    –  수확·선별 단계 자동 품질 검수로 인력 비용 절감 + 기준 일관성</a:t>
+            </a:r>
+          </a:p>
+          <a:p>
+            <a:pPr lvl="1">
+              <a:spcAft>
+                <a:spcPts val="600"/>
+              </a:spcAft>
+            </a:pPr>
+            <a:r>
+              <a:rPr sz="1500" b="0">
+                <a:solidFill>
+                  <a:srgbClr val="555555"/>
+                </a:solidFill>
+                <a:latin typeface="Malgun Gothic"/>
+              </a:rPr>
+              <a:t>    –  불량 과일 조기 제거로 유통·저장 중 오염 확산 방지</a:t>
             </a:r>
           </a:p>
           <a:p>
@@ -13843,7 +13875,7 @@
                 </a:solidFill>
                 <a:latin typeface="Malgun Gothic"/>
               </a:rPr>
-              <a:t>•  이미지 특성: 1920×1080, 배경 흰색 사전 처리됨</a:t>
+              <a:t>•  이미지 특성 — 수확·선별 단계 검수용 촬영본</a:t>
             </a:r>
           </a:p>
           <a:p>
@@ -13859,7 +13891,23 @@
                 </a:solidFill>
                 <a:latin typeface="Malgun Gothic"/>
               </a:rPr>
-              <a:t>    –  이미지당 감귤 1개 (단일 객체)</a:t>
+              <a:t>    –  꼭지 잘린 수확 후 과일을 흰 배경에 놓고 촬영</a:t>
+            </a:r>
+          </a:p>
+          <a:p>
+            <a:pPr lvl="1">
+              <a:spcAft>
+                <a:spcPts val="600"/>
+              </a:spcAft>
+            </a:pPr>
+            <a:r>
+              <a:rPr sz="1500" b="0">
+                <a:solidFill>
+                  <a:srgbClr val="555555"/>
+                </a:solidFill>
+                <a:latin typeface="Malgun Gothic"/>
+              </a:rPr>
+              <a:t>    –  1920×1080, 이미지당 감귤 1개 (단일 객체)</a:t>
             </a:r>
           </a:p>
           <a:p>

</xml_diff>